<commit_message>
Linux port fixes, live pipeline verification, dashboard light-theme redesign, live PEMS-BAY scoring
</commit_message>
<xml_diff>
--- a/Project_Presentation_Final.pptx
+++ b/Project_Presentation_Final.pptx
@@ -2731,7 +2731,7 @@
                 </a:solidFill>
                 <a:latin typeface="Times New Roman"/>
               </a:rPr>
-              <a:t>Forecasting data: PEMS-BAY Bay-Area sample (325 sensors, ≤150k rows/split, seed 42) with 12 lag features x_t-11…x_t and targets y_t+1/+3/+12. The small test CSV is still to be placed in data/raw/ — the page shows guidance until then.</a:t>
+              <a:t>Forecasting data: PEMS-BAY Bay-Area sample (325 sensors, ≤150k rows/split, seed 42) with 12 lag features x_t-11…x_t and targets y_t+1/+3/+12. A 100-row test sample in data/raw/ is scored live (see Results).</a:t>
             </a:r>
           </a:p>
           <a:p>
@@ -3168,7 +3168,7 @@
               </a:defRPr>
             </a:pPr>
             <a:r>
-              <a:t>Comparative Results (Recorded Test Metrics)</a:t>
+              <a:t>Comparative Results (Recorded + Live-Scored)</a:t>
             </a:r>
           </a:p>
         </p:txBody>
@@ -3319,7 +3319,7 @@
               </a:defRPr>
             </a:pPr>
             <a:r>
-              <a:t>Recorded test-split metrics from the sampled PEMS-BAY experiment (not live-computed; test CSV pending). Deployed model: RandomForest.</a:t>
+              <a:t>Recorded test-split metrics from the sampled PEMS-BAY experiment. Deployed model: RandomForest. Live-scored 100-row sample below.</a:t>
             </a:r>
           </a:p>
         </p:txBody>
@@ -4134,7 +4134,7 @@
               </a:defRPr>
             </a:pPr>
             <a:r>
-              <a:t>Reading: RandomForest wins all horizons; error grows with horizon (5-min R² 0.966 → 60-min R² 0.600) — near-term traffic is far more predictable.</a:t>
+              <a:t>Reading: RandomForest wins all horizons; error grows with horizon (5-min R² 0.966 → 60-min R² 0.600). Live 100-row sample: MAE 0.74/0.85/1.34, RMSE 0.93/1.08/1.84 — healthy; sample R² is negative only because the slice is near-constant (std ≈ 0.88).</a:t>
             </a:r>
           </a:p>
         </p:txBody>
@@ -4494,7 +4494,7 @@
                 </a:solidFill>
                 <a:latin typeface="Times New Roman"/>
               </a:rPr>
-              <a:t>Not claimed: browser-pixel rendering; live PEMS-BAY scoring (test CSV absent — sample-level predictions only).</a:t>
+              <a:t>Not claimed: browser-pixel rendering. PEMS-BAY is scored live on the 100-row sample (healthy MAE/RMSE; R² negative on the near-constant slice) — full-split scoring awaits the larger sample.</a:t>
             </a:r>
           </a:p>
         </p:txBody>
@@ -4793,7 +4793,7 @@
                 </a:solidFill>
                 <a:latin typeface="Times New Roman"/>
               </a:rPr>
-              <a:t>•  Genuine gaps remain: the PEMS-BAY test CSV must be supplied before live forecast scoring; the map needs a browser check.</a:t>
+              <a:t>•  Genuine gaps remaining: full-split forecast scoring needs the larger PEMS-BAY sample (only 100 rows on hand); the map still wants a browser pixel-check.</a:t>
             </a:r>
           </a:p>
         </p:txBody>
@@ -7346,7 +7346,7 @@
                 </a:solidFill>
                 <a:latin typeface="Times New Roman"/>
               </a:rPr>
-              <a:t>•  Separately, RandomForest regressors trained on sampled PEMS-BAY data forecast traffic at 5-, 15- and 60-minute horizons (recorded test R²: 0.966 / 0.889 / 0.600).</a:t>
+              <a:t>•  Separately, RandomForest regressors trained on sampled PEMS-BAY data forecast traffic at 5-, 15- and 60-minute horizons (recorded test R²: 0.966 / 0.889 / 0.600; live-scored on a 100-row sample with MAE 0.74 / 0.85 / 1.34).</a:t>
             </a:r>
           </a:p>
           <a:p>

</xml_diff>